<commit_message>
Complete Vision and AI provenance guidance
Add durable AI deployment model-change records, bounded Vision result retention, and a transport-neutral external result mapping. Update the shaded walkthrough and regenerated specification artifacts.

Co-authored-by: Copilot <223556219+Copilot@users.noreply.github.com>
</commit_message>
<xml_diff>
--- a/word-drafts/figures/Vision-Fig2-Instances.pptx
+++ b/word-drafts/figures/Vision-Fig2-Instances.pptx
@@ -4428,6 +4428,17 @@
                 </a:solidFill>
               </a:rPr>
               <a:t>State, Continuous</a:t>
+            </a:r>
+          </a:p>
+          <a:p>
+            <a:pPr algn="ctr"/>
+            <a:r>
+              <a:rPr sz="900">
+                <a:solidFill>
+                  <a:srgbClr val="111111"/>
+                </a:solidFill>
+              </a:rPr>
+              <a:t>MaxResultAge, MaxRetainedResults</a:t>
             </a:r>
           </a:p>
         </p:txBody>

</xml_diff>